<commit_message>
Fix parameters for hmc recovery
</commit_message>
<xml_diff>
--- a/talk/equations.pptx
+++ b/talk/equations.pptx
@@ -106,6 +106,11 @@
       </a:defRPr>
     </a:lvl9pPr>
   </p:defaultTextStyle>
+  <p:extLst>
+    <p:ext uri="{EFAFB233-063F-42B5-8137-9DF3F51BA10A}">
+      <p15:sldGuideLst xmlns:p15="http://schemas.microsoft.com/office/powerpoint/2012/main"/>
+    </p:ext>
+  </p:extLst>
 </p:presentation>
 </file>
 
@@ -258,7 +263,7 @@
           <a:p>
             <a:fld id="{B9DE27C0-378B-4390-BD47-909B218BE352}" type="datetimeFigureOut">
               <a:rPr lang="en-DE" smtClean="0"/>
-              <a:t>14/03/2023</a:t>
+              <a:t>18/03/2023</a:t>
             </a:fld>
             <a:endParaRPr lang="en-DE"/>
           </a:p>
@@ -458,7 +463,7 @@
           <a:p>
             <a:fld id="{B9DE27C0-378B-4390-BD47-909B218BE352}" type="datetimeFigureOut">
               <a:rPr lang="en-DE" smtClean="0"/>
-              <a:t>14/03/2023</a:t>
+              <a:t>18/03/2023</a:t>
             </a:fld>
             <a:endParaRPr lang="en-DE"/>
           </a:p>
@@ -668,7 +673,7 @@
           <a:p>
             <a:fld id="{B9DE27C0-378B-4390-BD47-909B218BE352}" type="datetimeFigureOut">
               <a:rPr lang="en-DE" smtClean="0"/>
-              <a:t>14/03/2023</a:t>
+              <a:t>18/03/2023</a:t>
             </a:fld>
             <a:endParaRPr lang="en-DE"/>
           </a:p>
@@ -868,7 +873,7 @@
           <a:p>
             <a:fld id="{B9DE27C0-378B-4390-BD47-909B218BE352}" type="datetimeFigureOut">
               <a:rPr lang="en-DE" smtClean="0"/>
-              <a:t>14/03/2023</a:t>
+              <a:t>18/03/2023</a:t>
             </a:fld>
             <a:endParaRPr lang="en-DE"/>
           </a:p>
@@ -1144,7 +1149,7 @@
           <a:p>
             <a:fld id="{B9DE27C0-378B-4390-BD47-909B218BE352}" type="datetimeFigureOut">
               <a:rPr lang="en-DE" smtClean="0"/>
-              <a:t>14/03/2023</a:t>
+              <a:t>18/03/2023</a:t>
             </a:fld>
             <a:endParaRPr lang="en-DE"/>
           </a:p>
@@ -1412,7 +1417,7 @@
           <a:p>
             <a:fld id="{B9DE27C0-378B-4390-BD47-909B218BE352}" type="datetimeFigureOut">
               <a:rPr lang="en-DE" smtClean="0"/>
-              <a:t>14/03/2023</a:t>
+              <a:t>18/03/2023</a:t>
             </a:fld>
             <a:endParaRPr lang="en-DE"/>
           </a:p>
@@ -1827,7 +1832,7 @@
           <a:p>
             <a:fld id="{B9DE27C0-378B-4390-BD47-909B218BE352}" type="datetimeFigureOut">
               <a:rPr lang="en-DE" smtClean="0"/>
-              <a:t>14/03/2023</a:t>
+              <a:t>18/03/2023</a:t>
             </a:fld>
             <a:endParaRPr lang="en-DE"/>
           </a:p>
@@ -1969,7 +1974,7 @@
           <a:p>
             <a:fld id="{B9DE27C0-378B-4390-BD47-909B218BE352}" type="datetimeFigureOut">
               <a:rPr lang="en-DE" smtClean="0"/>
-              <a:t>14/03/2023</a:t>
+              <a:t>18/03/2023</a:t>
             </a:fld>
             <a:endParaRPr lang="en-DE"/>
           </a:p>
@@ -2082,7 +2087,7 @@
           <a:p>
             <a:fld id="{B9DE27C0-378B-4390-BD47-909B218BE352}" type="datetimeFigureOut">
               <a:rPr lang="en-DE" smtClean="0"/>
-              <a:t>14/03/2023</a:t>
+              <a:t>18/03/2023</a:t>
             </a:fld>
             <a:endParaRPr lang="en-DE"/>
           </a:p>
@@ -2395,7 +2400,7 @@
           <a:p>
             <a:fld id="{B9DE27C0-378B-4390-BD47-909B218BE352}" type="datetimeFigureOut">
               <a:rPr lang="en-DE" smtClean="0"/>
-              <a:t>14/03/2023</a:t>
+              <a:t>18/03/2023</a:t>
             </a:fld>
             <a:endParaRPr lang="en-DE"/>
           </a:p>
@@ -2684,7 +2689,7 @@
           <a:p>
             <a:fld id="{B9DE27C0-378B-4390-BD47-909B218BE352}" type="datetimeFigureOut">
               <a:rPr lang="en-DE" smtClean="0"/>
-              <a:t>14/03/2023</a:t>
+              <a:t>18/03/2023</a:t>
             </a:fld>
             <a:endParaRPr lang="en-DE"/>
           </a:p>
@@ -2927,7 +2932,7 @@
           <a:p>
             <a:fld id="{B9DE27C0-378B-4390-BD47-909B218BE352}" type="datetimeFigureOut">
               <a:rPr lang="en-DE" smtClean="0"/>
-              <a:t>14/03/2023</a:t>
+              <a:t>18/03/2023</a:t>
             </a:fld>
             <a:endParaRPr lang="en-DE"/>
           </a:p>
@@ -3346,10 +3351,10 @@
       </p:grpSpPr>
       <p:pic>
         <p:nvPicPr>
-          <p:cNvPr id="35" name="Picture 34" descr="\documentclass{article}&#10;\usepackage{amsmath}&#10;\pagestyle{empty}&#10;\begin{document}&#10;&#10;$$&#10;p(&#10;\overbrace{T_t}^{\text{Target}} \mid \underbrace{u_{1:t}}_{\text{Sentence}}, T_{1:t-1}, \overbrace{S_{1:t}}^{\text{Scene}}) = &#10;\sum_{\text{lang } i} &#10;\overbrace{p(i \mid u_{1:t-1}, T_{1:t-1}, S_{1:t-1})}^{\text{Belief update model}}&#10;\underbrace{p(T_t \mid u_t, S_t, i)}_{\text{Belief model}}&#10;$$&#10;&#10;\end{document}" title="IguanaTex Bitmap Display">
-            <a:extLst>
-              <a:ext uri="{FF2B5EF4-FFF2-40B4-BE49-F238E27FC236}">
-                <a16:creationId xmlns:a16="http://schemas.microsoft.com/office/drawing/2014/main" id="{566FF920-3A79-3969-67FD-B388C3EB10AE}"/>
+          <p:cNvPr id="3" name="Picture 2" descr="\documentclass{article}&#10;\usepackage{amsmath}&#10;\pagestyle{empty}&#10;\begin{document}&#10;&#10;$$&#10;p(&#10;\overbrace{T_t}^{\text{Target}} \mid \underbrace{u_{1:t}}_{\text{Sentence}}, T_{1:t-1}, \overbrace{S_{1:t}}^{\text{Scene}}) = &#10;\sum_{\text{lang } i} &#10;\overbrace{p(i \mid u_{1:t-1}, T_{1:t-1}, S_{1:t-1})}^{\text{Beliefs about the language}}&#10;\underbrace{p(T_t \mid u_t, S_t, i)}_{\text{Beliefs about the trial}}&#10;$$&#10;&#10;\end{document}" title="IguanaTex Bitmap Display">
+            <a:extLst>
+              <a:ext uri="{FF2B5EF4-FFF2-40B4-BE49-F238E27FC236}">
+                <a16:creationId xmlns:a16="http://schemas.microsoft.com/office/drawing/2014/main" id="{B2C31A28-3829-C847-015B-3D7208168EAB}"/>
               </a:ext>
             </a:extLst>
           </p:cNvPr>
@@ -3376,8 +3381,8 @@
         </p:blipFill>
         <p:spPr>
           <a:xfrm>
-            <a:off x="1681164" y="1094109"/>
-            <a:ext cx="8201021" cy="948542"/>
+            <a:off x="1531039" y="1235136"/>
+            <a:ext cx="8557532" cy="949915"/>
           </a:xfrm>
           <a:prstGeom prst="rect">
             <a:avLst/>
@@ -3541,12 +3546,12 @@
 <p:tagLst xmlns:a="http://schemas.openxmlformats.org/drawingml/2006/main" xmlns:r="http://schemas.openxmlformats.org/officeDocument/2006/relationships" xmlns:p="http://schemas.openxmlformats.org/presentationml/2006/main">
   <p:tag name="OUTPUTDPI" val="1200"/>
   <p:tag name="ORIGINALHEIGHT" val="477,6903"/>
-  <p:tag name="ORIGINALWIDTH" val="4220,473"/>
+  <p:tag name="ORIGINALWIDTH" val="4403,449"/>
   <p:tag name="OUTPUTTYPE" val="PNG"/>
   <p:tag name="IGUANATEXVERSION" val="160"/>
-  <p:tag name="LATEXADDIN" val="\documentclass{article}&#10;\usepackage{amsmath}&#10;\pagestyle{empty}&#10;\begin{document}&#10;&#10;$$&#10;p(&#10;\overbrace{T_t}^{\text{Target}} \mid \underbrace{u_{1:t}}_{\text{Sentence}}, T_{1:t-1}, \overbrace{S_{1:t}}^{\text{Scene}}) = &#10;\sum_{\text{lang } i} &#10;\overbrace{p(i \mid u_{1:t-1}, T_{1:t-1}, S_{1:t-1})}^{\text{Belief update model}}&#10;\underbrace{p(T_t \mid u_t, S_t, i)}_{\text{Belief model}}&#10;$$&#10;&#10;\end{document}"/>
+  <p:tag name="LATEXADDIN" val="\documentclass{article}&#10;\usepackage{amsmath}&#10;\pagestyle{empty}&#10;\begin{document}&#10;&#10;$$&#10;p(&#10;\overbrace{T_t}^{\text{Target}} \mid \underbrace{u_{1:t}}_{\text{Sentence}}, T_{1:t-1}, \overbrace{S_{1:t}}^{\text{Scene}}) = &#10;\sum_{\text{lang } i} &#10;\overbrace{p(i \mid u_{1:t-1}, T_{1:t-1}, S_{1:t-1})}^{\text{Beliefs about the language}}&#10;\underbrace{p(T_t \mid u_t, S_t, i)}_{\text{Beliefs about the trial}}&#10;$$&#10;&#10;\end{document}"/>
   <p:tag name="IGUANATEXSIZE" val="20"/>
-  <p:tag name="IGUANATEXCURSOR" val="311"/>
+  <p:tag name="IGUANATEXCURSOR" val="394"/>
   <p:tag name="TRANSPARENCY" val="True"/>
   <p:tag name="LATEXENGINEID" val="0"/>
   <p:tag name="TEMPFOLDER" val="C:\temp\"/>

</xml_diff>